<commit_message>
Cite the release commit 383092e in the README, notebook, paper copy and poster
The release commit is the course-organization merge 383092e, which carries the
tested revision 0077ad6; both trees are dadbb0b2ee2e. Nothing in code/,
verify_k.py, hf_space/ or the result files changes: this commit only adds the
citation, so the tested release stays reproducible at 383092e.
</commit_message>
<xml_diff>
--- a/poster/PS2-FP04-A0-Poster.pptx
+++ b/poster/PS2-FP04-A0-Poster.pptx
@@ -5205,11 +5205,11 @@
             <a:r>
               <a:rPr sz="1520" b="0">
                 <a:solidFill>
-                  <a:srgbClr val="C00000"/>
-                </a:solidFill>
-                <a:latin typeface="Calibri"/>
-              </a:rPr>
-              <a:t>Commit 【填：最终 commit】</a:t>
+                  <a:srgbClr val="212A33"/>
+                </a:solidFill>
+                <a:latin typeface="Calibri"/>
+              </a:rPr>
+              <a:t>Commit 383092e</a:t>
             </a:r>
             <a:r>
               <a:rPr sz="1520" b="0">

</xml_diff>